<commit_message>
docs: agregar TP de Gabriela Coronel
</commit_message>
<xml_diff>
--- a/TP_Integrador/presentacion/TP_Gabriela_Coronel.pptx
+++ b/TP_Integrador/presentacion/TP_Gabriela_Coronel.pptx
@@ -3194,10 +3194,10 @@
         </p:nvGrpSpPr>
         <p:grpSpPr>
           <a:xfrm rot="0">
-            <a:off x="14147789" y="0"/>
-            <a:ext cx="9527932" cy="4058609"/>
+            <a:off x="14147787" y="0"/>
+            <a:ext cx="9527953" cy="4058612"/>
             <a:chOff x="0" y="0"/>
-            <a:chExt cx="17582113" cy="7489444"/>
+            <a:chExt cx="12703937" cy="5411483"/>
           </a:xfrm>
         </p:grpSpPr>
         <p:sp>
@@ -3209,7 +3209,7 @@
           <p:spPr>
             <a:xfrm flipH="false" flipV="false" rot="0">
               <a:off x="0" y="0"/>
-              <a:ext cx="17582152" cy="7489444"/>
+              <a:ext cx="12703937" cy="5411470"/>
             </a:xfrm>
             <a:custGeom>
               <a:avLst/>
@@ -3218,18 +3218,18 @@
               <a:cxnLst/>
               <a:rect r="r" b="b" t="t" l="l"/>
               <a:pathLst>
-                <a:path h="7489444" w="17582152">
+                <a:path h="5411470" w="12703937">
                   <a:moveTo>
                     <a:pt x="0" y="0"/>
                   </a:moveTo>
                   <a:lnTo>
-                    <a:pt x="17582152" y="0"/>
+                    <a:pt x="12703937" y="0"/>
                   </a:lnTo>
                   <a:lnTo>
-                    <a:pt x="17582152" y="7489444"/>
+                    <a:pt x="12703937" y="5411470"/>
                   </a:lnTo>
                   <a:lnTo>
-                    <a:pt x="0" y="7489444"/>
+                    <a:pt x="0" y="5411470"/>
                   </a:lnTo>
                   <a:lnTo>
                     <a:pt x="0" y="0"/>
@@ -3270,7 +3270,7 @@
           <a:p>
             <a:pPr algn="l">
               <a:lnSpc>
-                <a:spcPts val="2341"/>
+                <a:spcPts val="2340"/>
               </a:lnSpc>
             </a:pPr>
             <a:r>
@@ -3311,7 +3311,7 @@
           <a:p>
             <a:pPr algn="l">
               <a:lnSpc>
-                <a:spcPts val="7564"/>
+                <a:spcPts val="7563"/>
               </a:lnSpc>
             </a:pPr>
             <a:r>
@@ -3352,7 +3352,7 @@
           <a:p>
             <a:pPr algn="l">
               <a:lnSpc>
-                <a:spcPts val="4142"/>
+                <a:spcPts val="4141"/>
               </a:lnSpc>
             </a:pPr>
             <a:r>
@@ -3378,8 +3378,8 @@
         </p:nvSpPr>
         <p:spPr>
           <a:xfrm rot="0">
-            <a:off x="1326842" y="7233199"/>
-            <a:ext cx="13543845" cy="545316"/>
+            <a:off x="1326842" y="7223674"/>
+            <a:ext cx="13543845" cy="554841"/>
           </a:xfrm>
           <a:prstGeom prst="rect">
             <a:avLst/>
@@ -3596,7 +3596,7 @@
           <a:p>
             <a:pPr algn="l">
               <a:lnSpc>
-                <a:spcPts val="5223"/>
+                <a:spcPts val="5222"/>
               </a:lnSpc>
             </a:pPr>
             <a:r>
@@ -3757,7 +3757,7 @@
           <a:p>
             <a:pPr algn="l">
               <a:lnSpc>
-                <a:spcPts val="1560"/>
+                <a:spcPts val="1559"/>
               </a:lnSpc>
             </a:pPr>
             <a:r>
@@ -3864,9 +3864,9 @@
         <p:grpSpPr>
           <a:xfrm rot="0">
             <a:off x="5872991" y="2601211"/>
-            <a:ext cx="7974092" cy="5316064"/>
+            <a:ext cx="7974140" cy="5316093"/>
             <a:chOff x="0" y="0"/>
-            <a:chExt cx="10632122" cy="7088086"/>
+            <a:chExt cx="10632186" cy="7088124"/>
           </a:xfrm>
         </p:grpSpPr>
         <p:sp>
@@ -3910,7 +3910,7 @@
             <a:blipFill>
               <a:blip r:embed="rId2"/>
               <a:stretch>
-                <a:fillRect l="-23" t="0" r="-22" b="0"/>
+                <a:fillRect l="-23" t="0" r="-23" b="0"/>
               </a:stretch>
             </a:blipFill>
           </p:spPr>
@@ -3980,7 +3980,7 @@
           <a:p>
             <a:pPr algn="l">
               <a:lnSpc>
-                <a:spcPts val="5223"/>
+                <a:spcPts val="5222"/>
               </a:lnSpc>
             </a:pPr>
             <a:r>
@@ -4062,7 +4062,7 @@
           <a:p>
             <a:pPr algn="l">
               <a:lnSpc>
-                <a:spcPts val="3061"/>
+                <a:spcPts val="3060"/>
               </a:lnSpc>
             </a:pPr>
             <a:r>
@@ -4081,7 +4081,7 @@
           <a:p>
             <a:pPr algn="l">
               <a:lnSpc>
-                <a:spcPts val="3061"/>
+                <a:spcPts val="3060"/>
               </a:lnSpc>
             </a:pPr>
             <a:r>
@@ -4100,7 +4100,7 @@
           <a:p>
             <a:pPr algn="l">
               <a:lnSpc>
-                <a:spcPts val="3061"/>
+                <a:spcPts val="3060"/>
               </a:lnSpc>
             </a:pPr>
             <a:r>
@@ -4119,7 +4119,7 @@
           <a:p>
             <a:pPr algn="l">
               <a:lnSpc>
-                <a:spcPts val="3061"/>
+                <a:spcPts val="3060"/>
               </a:lnSpc>
             </a:pPr>
             <a:r>
@@ -4160,7 +4160,7 @@
           <a:p>
             <a:pPr algn="l">
               <a:lnSpc>
-                <a:spcPts val="1440"/>
+                <a:spcPts val="1439"/>
               </a:lnSpc>
             </a:pPr>
             <a:r>
@@ -4267,9 +4267,9 @@
         <p:grpSpPr>
           <a:xfrm rot="0">
             <a:off x="4715942" y="5228739"/>
-            <a:ext cx="7853953" cy="4029561"/>
+            <a:ext cx="7853934" cy="4029551"/>
             <a:chOff x="0" y="0"/>
-            <a:chExt cx="10471937" cy="5372748"/>
+            <a:chExt cx="10471912" cy="5372735"/>
           </a:xfrm>
         </p:grpSpPr>
         <p:sp>
@@ -4313,7 +4313,7 @@
             <a:blipFill>
               <a:blip r:embed="rId2"/>
               <a:stretch>
-                <a:fillRect l="0" t="-4393" r="0" b="-4393"/>
+                <a:fillRect l="0" t="-4388" r="0" b="-4388"/>
               </a:stretch>
             </a:blipFill>
           </p:spPr>
@@ -4342,7 +4342,7 @@
           <a:p>
             <a:pPr algn="l">
               <a:lnSpc>
-                <a:spcPts val="3241"/>
+                <a:spcPts val="3240"/>
               </a:lnSpc>
             </a:pPr>
             <a:r>
@@ -4361,7 +4361,7 @@
           <a:p>
             <a:pPr algn="l">
               <a:lnSpc>
-                <a:spcPts val="3241"/>
+                <a:spcPts val="3240"/>
               </a:lnSpc>
             </a:pPr>
             <a:r>
@@ -4380,7 +4380,7 @@
           <a:p>
             <a:pPr algn="l">
               <a:lnSpc>
-                <a:spcPts val="3241"/>
+                <a:spcPts val="3240"/>
               </a:lnSpc>
             </a:pPr>
             <a:r>
@@ -4399,7 +4399,7 @@
           <a:p>
             <a:pPr algn="l">
               <a:lnSpc>
-                <a:spcPts val="3241"/>
+                <a:spcPts val="3240"/>
               </a:lnSpc>
             </a:pPr>
             <a:r>
@@ -4418,7 +4418,7 @@
           <a:p>
             <a:pPr algn="l">
               <a:lnSpc>
-                <a:spcPts val="3241"/>
+                <a:spcPts val="3240"/>
               </a:lnSpc>
             </a:pPr>
             <a:r>
@@ -4500,7 +4500,7 @@
           <a:p>
             <a:pPr algn="l">
               <a:lnSpc>
-                <a:spcPts val="5223"/>
+                <a:spcPts val="5222"/>
               </a:lnSpc>
             </a:pPr>
             <a:r>
@@ -4582,7 +4582,7 @@
           <a:p>
             <a:pPr algn="l">
               <a:lnSpc>
-                <a:spcPts val="1560"/>
+                <a:spcPts val="1559"/>
               </a:lnSpc>
             </a:pPr>
             <a:r>
@@ -4744,7 +4744,7 @@
           <a:p>
             <a:pPr algn="l">
               <a:lnSpc>
-                <a:spcPts val="5223"/>
+                <a:spcPts val="5222"/>
               </a:lnSpc>
             </a:pPr>
             <a:r>
@@ -4924,7 +4924,7 @@
           <a:p>
             <a:pPr algn="l">
               <a:lnSpc>
-                <a:spcPts val="1440"/>
+                <a:spcPts val="1439"/>
               </a:lnSpc>
             </a:pPr>
             <a:r>
@@ -5086,7 +5086,7 @@
           <a:p>
             <a:pPr algn="l">
               <a:lnSpc>
-                <a:spcPts val="5223"/>
+                <a:spcPts val="5222"/>
               </a:lnSpc>
             </a:pPr>
             <a:r>
@@ -5153,8 +5153,8 @@
         </p:nvSpPr>
         <p:spPr>
           <a:xfrm rot="0">
-            <a:off x="1326842" y="3252454"/>
-            <a:ext cx="16054511" cy="2114217"/>
+            <a:off x="1326842" y="3242929"/>
+            <a:ext cx="16054511" cy="2123742"/>
           </a:xfrm>
           <a:prstGeom prst="rect">
             <a:avLst/>
@@ -5266,7 +5266,7 @@
           <a:p>
             <a:pPr algn="l">
               <a:lnSpc>
-                <a:spcPts val="1440"/>
+                <a:spcPts val="1439"/>
               </a:lnSpc>
             </a:pPr>
             <a:r>
@@ -5428,7 +5428,7 @@
           <a:p>
             <a:pPr algn="l">
               <a:lnSpc>
-                <a:spcPts val="5223"/>
+                <a:spcPts val="5222"/>
               </a:lnSpc>
             </a:pPr>
             <a:r>
@@ -5510,7 +5510,7 @@
           <a:p>
             <a:pPr algn="l">
               <a:lnSpc>
-                <a:spcPts val="3061"/>
+                <a:spcPts val="3060"/>
               </a:lnSpc>
             </a:pPr>
             <a:r>
@@ -5529,7 +5529,7 @@
           <a:p>
             <a:pPr algn="l">
               <a:lnSpc>
-                <a:spcPts val="3061"/>
+                <a:spcPts val="3060"/>
               </a:lnSpc>
             </a:pPr>
             <a:r>
@@ -5548,7 +5548,7 @@
           <a:p>
             <a:pPr algn="l">
               <a:lnSpc>
-                <a:spcPts val="3061"/>
+                <a:spcPts val="3060"/>
               </a:lnSpc>
             </a:pPr>
             <a:r>
@@ -5567,7 +5567,7 @@
           <a:p>
             <a:pPr algn="l">
               <a:lnSpc>
-                <a:spcPts val="3061"/>
+                <a:spcPts val="3060"/>
               </a:lnSpc>
             </a:pPr>
             <a:r>
@@ -5608,7 +5608,7 @@
           <a:p>
             <a:pPr algn="l">
               <a:lnSpc>
-                <a:spcPts val="1440"/>
+                <a:spcPts val="1439"/>
               </a:lnSpc>
             </a:pPr>
             <a:r>
@@ -5635,7 +5635,7 @@
 </file>
 
 <file path=ppt/slides/slide8.xml><?xml version="1.0" encoding="utf-8"?>
-<p:sld xmlns:p="http://schemas.openxmlformats.org/presentationml/2006/main" xmlns:a="http://schemas.openxmlformats.org/drawingml/2006/main">
+<p:sld xmlns:p="http://schemas.openxmlformats.org/presentationml/2006/main" xmlns:a="http://schemas.openxmlformats.org/drawingml/2006/main" xmlns:r="http://schemas.openxmlformats.org/officeDocument/2006/relationships">
   <p:cSld>
     <p:spTree>
       <p:nvGrpSpPr>
@@ -5770,7 +5770,7 @@
           <a:p>
             <a:pPr algn="l">
               <a:lnSpc>
-                <a:spcPts val="5223"/>
+                <a:spcPts val="5222"/>
               </a:lnSpc>
             </a:pPr>
             <a:r>
@@ -5837,8 +5837,8 @@
         </p:nvSpPr>
         <p:spPr>
           <a:xfrm rot="0">
-            <a:off x="1326842" y="3271504"/>
-            <a:ext cx="15465590" cy="5673785"/>
+            <a:off x="1326842" y="3052429"/>
+            <a:ext cx="15465590" cy="4713619"/>
           </a:xfrm>
           <a:prstGeom prst="rect">
             <a:avLst/>
@@ -5852,77 +5852,137 @@
           <a:p>
             <a:pPr algn="l">
               <a:lnSpc>
-                <a:spcPts val="3061"/>
-              </a:lnSpc>
-            </a:pPr>
-            <a:r>
-              <a:rPr lang="en-US" sz="2550">
-                <a:solidFill>
-                  <a:srgbClr val="DEDCD8"/>
+                <a:spcPts val="5509"/>
+              </a:lnSpc>
+            </a:pPr>
+            <a:r>
+              <a:rPr lang="en-US" sz="2699">
+                <a:solidFill>
+                  <a:srgbClr val="F5F2EE"/>
                 </a:solidFill>
                 <a:latin typeface="Aptos"/>
                 <a:ea typeface="Aptos"/>
                 <a:cs typeface="Aptos"/>
                 <a:sym typeface="Aptos"/>
               </a:rPr>
-              <a:t>•  Demo pública en Hugging Face Spaces.</a:t>
-            </a:r>
-          </a:p>
-          <a:p>
-            <a:pPr algn="l">
-              <a:lnSpc>
-                <a:spcPts val="3061"/>
-              </a:lnSpc>
-            </a:pPr>
-            <a:r>
-              <a:rPr lang="en-US" sz="2550">
-                <a:solidFill>
-                  <a:srgbClr val="DEDCD8"/>
+              <a:t>•  Demo pública en Hugging Face Spaces: huggingface.co/spaces/lagabyok/bugtriage-ai</a:t>
+            </a:r>
+          </a:p>
+          <a:p>
+            <a:pPr algn="l">
+              <a:lnSpc>
+                <a:spcPts val="3239"/>
+              </a:lnSpc>
+            </a:pPr>
+            <a:r>
+              <a:rPr lang="en-US" sz="2699">
+                <a:solidFill>
+                  <a:srgbClr val="F5F2EE"/>
                 </a:solidFill>
                 <a:latin typeface="Aptos"/>
                 <a:ea typeface="Aptos"/>
                 <a:cs typeface="Aptos"/>
                 <a:sym typeface="Aptos"/>
               </a:rPr>
-              <a:t>•  La IA generativa se utilizó como apoyo documental y técnico; el código y resultados se revisaron.</a:t>
-            </a:r>
-          </a:p>
-          <a:p>
-            <a:pPr algn="l">
-              <a:lnSpc>
-                <a:spcPts val="3061"/>
-              </a:lnSpc>
-            </a:pPr>
-            <a:r>
-              <a:rPr lang="en-US" sz="2550">
-                <a:solidFill>
-                  <a:srgbClr val="DEDCD8"/>
+              <a:t> Elegí Spaces porque permite publicar una demo accesible desde el navegador e integrar Gradio sin pedirle al evaluador que instale el proyecto.</a:t>
+            </a:r>
+          </a:p>
+          <a:p>
+            <a:pPr algn="l">
+              <a:lnSpc>
+                <a:spcPts val="3239"/>
+              </a:lnSpc>
+            </a:pPr>
+          </a:p>
+          <a:p>
+            <a:pPr algn="l">
+              <a:lnSpc>
+                <a:spcPts val="3239"/>
+              </a:lnSpc>
+            </a:pPr>
+            <a:r>
+              <a:rPr lang="en-US" sz="2699">
+                <a:solidFill>
+                  <a:srgbClr val="F5F2EE"/>
                 </a:solidFill>
                 <a:latin typeface="Aptos"/>
                 <a:ea typeface="Aptos"/>
                 <a:cs typeface="Aptos"/>
                 <a:sym typeface="Aptos"/>
               </a:rPr>
-              <a:t>•  La solución demuestra inferencia con un modelo preentrenado y despliegue de una interfaz.</a:t>
-            </a:r>
-          </a:p>
-          <a:p>
-            <a:pPr algn="l">
-              <a:lnSpc>
-                <a:spcPts val="3061"/>
-              </a:lnSpc>
-            </a:pPr>
-            <a:r>
-              <a:rPr lang="en-US" sz="2550">
-                <a:solidFill>
-                  <a:srgbClr val="DEDCD8"/>
+              <a:t>•  Repositorio académico (código, notebook, resultados e informe):</a:t>
+            </a:r>
+          </a:p>
+          <a:p>
+            <a:pPr algn="l">
+              <a:lnSpc>
+                <a:spcPts val="2639"/>
+              </a:lnSpc>
+            </a:pPr>
+            <a:r>
+              <a:rPr lang="en-US" sz="2199" u="sng">
+                <a:solidFill>
+                  <a:srgbClr val="0000FF"/>
+                </a:solidFill>
+                <a:latin typeface="Aptos"/>
+                <a:ea typeface="Aptos"/>
+                <a:cs typeface="Aptos"/>
+                <a:sym typeface="Aptos"/>
+                <a:hlinkClick r:id="rId2" tooltip="https://github.com/lagabyok/Gabriela-Coronel-seminario-de-actualizacion-2026/tree/main/TP_Integrador"/>
+              </a:rPr>
+              <a:t>   https://github.com/lagabyok/Gabriela-Coronel-seminario-de-actualizacion-2026/tree/main/TP_Integrador</a:t>
+            </a:r>
+          </a:p>
+          <a:p>
+            <a:pPr algn="l">
+              <a:lnSpc>
+                <a:spcPts val="2639"/>
+              </a:lnSpc>
+            </a:pPr>
+          </a:p>
+          <a:p>
+            <a:pPr algn="l">
+              <a:lnSpc>
+                <a:spcPts val="3239"/>
+              </a:lnSpc>
+            </a:pPr>
+            <a:r>
+              <a:rPr lang="en-US" sz="2699">
+                <a:solidFill>
+                  <a:srgbClr val="F5F2EE"/>
                 </a:solidFill>
                 <a:latin typeface="Aptos"/>
                 <a:ea typeface="Aptos"/>
                 <a:cs typeface="Aptos"/>
                 <a:sym typeface="Aptos"/>
               </a:rPr>
-              <a:t>•  Conclusión: puede acelerar una primera lectura, pero necesita evaluación ampliada y supervisión humana.</a:t>
+              <a:t>  La IA generativa se utilizó como apoyo documental y  apoyo tecnico, con creacion y revision humana.</a:t>
+            </a:r>
+          </a:p>
+          <a:p>
+            <a:pPr algn="l">
+              <a:lnSpc>
+                <a:spcPts val="3239"/>
+              </a:lnSpc>
+            </a:pPr>
+          </a:p>
+          <a:p>
+            <a:pPr algn="l">
+              <a:lnSpc>
+                <a:spcPts val="3239"/>
+              </a:lnSpc>
+            </a:pPr>
+            <a:r>
+              <a:rPr lang="en-US" sz="2699" b="true">
+                <a:solidFill>
+                  <a:srgbClr val="F5F2EE"/>
+                </a:solidFill>
+                <a:latin typeface="Aptos Bold"/>
+                <a:ea typeface="Aptos Bold"/>
+                <a:cs typeface="Aptos Bold"/>
+                <a:sym typeface="Aptos Bold"/>
+              </a:rPr>
+              <a:t>  Conclusión: puede ayudar en una primera lectura, pero necesita más evaluación y supervisión humana.</a:t>
             </a:r>
           </a:p>
         </p:txBody>
@@ -5950,7 +6010,7 @@
           <a:p>
             <a:pPr algn="l">
               <a:lnSpc>
-                <a:spcPts val="1440"/>
+                <a:spcPts val="1439"/>
               </a:lnSpc>
             </a:pPr>
             <a:r>

</xml_diff>